<commit_message>
Faster runs, trace and usage stats, evaluation, clinical UI, audit trail, daily run cap
</commit_message>
<xml_diff>
--- a/deck/case-prep-deck.pptx
+++ b/deck/case-prep-deck.pptx
@@ -111,18 +111,18 @@
   <p:extLst>
     <p:ext uri="{521415D9-36F7-43E2-AB2F-B90AF26B5E84}">
       <p14:sectionLst xmlns:p14="http://schemas.microsoft.com/office/powerpoint/2010/main">
-        <p14:section name="Setup" id="{5d43fc9c-5deb-6cbf-e554-2141ad15d0cc}">
+        <p14:section name="Setup" id="{01c15aa2-99b0-e163-f5e0-88f47e305dcb}">
           <p14:sldIdLst>
             <p14:sldId id="256"/>
             <p14:sldId id="257"/>
           </p14:sldIdLst>
         </p14:section>
-        <p14:section name="Demo" id="{79c89891-194e-74b4-8e9f-8f9a1f4848e9}">
+        <p14:section name="Demo" id="{5e64b9d8-13fd-3871-294b-dffba0f733d9}">
           <p14:sldIdLst>
             <p14:sldId id="258"/>
           </p14:sldIdLst>
         </p14:section>
-        <p14:section name="Value" id="{f93da1bb-8e4f-4673-c685-32836a8734fa}">
+        <p14:section name="Value" id="{7ae744a5-5c83-50b4-fcfc-866318b78822}">
           <p14:sldIdLst>
             <p14:sldId id="259"/>
             <p14:sldId id="260"/>
@@ -995,7 +995,7 @@
           <a:p>
             <a:r>
               <a:rPr lang="en-US" dirty="0"/>
-              <a:t>A live run takes about two and a half minutes, so start it before you begin the walkthrough and narrate while it works. The architecture: the browser app signs in with Cognito and calls the agent running on AgentCore. The agent reads the patient record through an MCP server, searches pathway documents with File Search, and calls the model through the Responses API. Run state and the audit trail are in DynamoDB.</a:t>
+              <a:t>This slide is the OpenAI side. A manager agent on gpt-6.1-sol starts three specialists together. The patient data and history specialists read the record through an MCP server. The evidence specialist searches the pathway documents with File Search and looks up PubMed. The specialists use gpt-6.1-terra, which is faster and cheaper, because they are reading and extracting. A separate verifier checks the draft. Then the run pauses for the oncologist. Everything runs in the customer's own AWS account; only model calls and pathway search go to OpenAI.</a:t>
             </a:r>
             <a:endParaRPr lang="en-US" dirty="0"/>
           </a:p>
@@ -1083,7 +1083,7 @@
           <a:p>
             <a:r>
               <a:rPr lang="en-US" dirty="0"/>
-              <a:t>Be plain about the numbers. These are assumptions: 40 cases a month, 75 minutes of preparation today, 25 minutes of review with the assistant, and a blended 120 dollars an hour. That gives about 33 hours a month. The dollar figure is modest. The bigger reason to do this is quality: catching a mismatch between sources before the meeting. We would measure that in a pilot.</a:t>
+              <a:t>Separate measured from assumed. Measured on the synthetic case: about 88 seconds of agent work and under ten cents of model cost per case, and the checks on the planted problems passed in every one of ten runs. Assumed: forty cases a month and preparation dropping from seventy-five minutes to twenty-five, which gives about thirty-three hours a month. The dollar value of that time is modest. The bigger reason is catching conflicts before the meeting, which a pilot would measure.</a:t>
             </a:r>
             <a:endParaRPr lang="en-US" dirty="0"/>
           </a:p>
@@ -2943,7 +2943,7 @@
                   <a:schemeClr val="tx1"/>
                 </a:solidFill>
               </a:rPr>
-              <a:t>What the demo shows</a:t>
+              <a:t>How it works</a:t>
             </a:r>
             <a:endParaRPr lang="en-US" sz="3400" dirty="0"/>
           </a:p>
@@ -2951,7 +2951,7 @@
       </p:sp>
       <p:pic>
         <p:nvPicPr>
-          <p:cNvPr id="3" name="Architecture diagram" descr="Architecture: React app on Amplify, Cognito, AgentCore Runtime, MCP server and DynamoDB in the customer AWS account, calling the OpenAI Platform and public APIs">    </p:cNvPr>
+          <p:cNvPr id="3" name="Agent graph" descr="Agent graph: the oncologist's request goes to a manager agent, which starts three specialists together (patient data, clinical history, evidence). A verifier checks the draft, a clinician approves, and the note is saved with an audit trail.">    </p:cNvPr>
           <p:cNvPicPr>
             <a:picLocks noChangeAspect="1"/>
           </p:cNvPicPr>
@@ -2965,8 +2965,8 @@
         </p:blipFill>
         <p:spPr>
           <a:xfrm>
-            <a:off x="548640" y="1417320"/>
-            <a:ext cx="6766560" cy="3977640"/>
+            <a:off x="548640" y="1371600"/>
+            <a:ext cx="6675120" cy="4197096"/>
           </a:xfrm>
           <a:prstGeom prst="rect">
             <a:avLst/>
@@ -2975,14 +2975,14 @@
       </p:pic>
       <p:sp>
         <p:nvSpPr>
-          <p:cNvPr id="4" name="Diagram caption"/>
+          <p:cNvPr id="4" name="Graph caption"/>
           <p:cNvSpPr txBox="1"/>
           <p:nvPr/>
         </p:nvSpPr>
         <p:spPr>
           <a:xfrm>
-            <a:off x="548640" y="5532120"/>
-            <a:ext cx="6766560" cy="640080"/>
+            <a:off x="548640" y="5669280"/>
+            <a:ext cx="6675120" cy="640080"/>
           </a:xfrm>
           <a:prstGeom prst="rect">
             <a:avLst/>
@@ -3003,7 +3003,7 @@
                   <a:schemeClr val="accent4"/>
                 </a:solidFill>
               </a:rPr>
-              <a:t>The agents run in the customer's AWS account. Only model calls and pathway search go to OpenAI.</a:t>
+              <a:t>Runs in the customer's AWS account: Cognito sign-in, AgentCore Runtime, an MCP server for the record, and DynamoDB for run state and the audit trail.</a:t>
             </a:r>
             <a:endParaRPr lang="en-US" sz="1400" dirty="0"/>
           </a:p>
@@ -3011,14 +3011,14 @@
       </p:sp>
       <p:sp>
         <p:nvSpPr>
-          <p:cNvPr id="5" name="Run of show card"/>
+          <p:cNvPr id="5" name="Steps card"/>
           <p:cNvSpPr/>
           <p:nvPr/>
         </p:nvSpPr>
         <p:spPr>
           <a:xfrm>
-            <a:off x="7589520" y="1417320"/>
-            <a:ext cx="4069080" cy="4754880"/>
+            <a:off x="7589520" y="1371600"/>
+            <a:ext cx="4069080" cy="4937760"/>
           </a:xfrm>
           <a:prstGeom prst="roundRect">
             <a:avLst>
@@ -3038,13 +3038,13 @@
       </p:sp>
       <p:sp>
         <p:nvSpPr>
-          <p:cNvPr id="6" name="Run of show heading"/>
+          <p:cNvPr id="6" name="Steps heading"/>
           <p:cNvSpPr txBox="1"/>
           <p:nvPr/>
         </p:nvSpPr>
         <p:spPr>
           <a:xfrm>
-            <a:off x="7818120" y="1554480"/>
+            <a:off x="7818120" y="1508760"/>
             <a:ext cx="3657600" cy="411480"/>
           </a:xfrm>
           <a:prstGeom prst="rect">
@@ -3066,7 +3066,7 @@
                   <a:schemeClr val="tx1"/>
                 </a:solidFill>
               </a:rPr>
-              <a:t>Five-minute run of show</a:t>
+              <a:t>What happens in a run</a:t>
             </a:r>
             <a:endParaRPr lang="en-US" sz="1800" dirty="0"/>
           </a:p>
@@ -3074,14 +3074,39 @@
       </p:sp>
       <p:sp>
         <p:nvSpPr>
-          <p:cNvPr id="7" name="Time 1"/>
+          <p:cNvPr id="7" name="Step badge 1"/>
+          <p:cNvSpPr/>
+          <p:nvPr/>
+        </p:nvSpPr>
+        <p:spPr>
+          <a:xfrm>
+            <a:off x="7818120" y="2148840"/>
+            <a:ext cx="411480" cy="411480"/>
+          </a:xfrm>
+          <a:prstGeom prst="ellipse">
+            <a:avLst/>
+          </a:prstGeom>
+          <a:solidFill>
+            <a:schemeClr val="accent1"/>
+          </a:solidFill>
+          <a:ln w="12700">
+            <a:solidFill>
+              <a:schemeClr val="accent1"/>
+            </a:solidFill>
+            <a:prstDash val="solid"/>
+          </a:ln>
+        </p:spPr>
+      </p:sp>
+      <p:sp>
+        <p:nvSpPr>
+          <p:cNvPr id="8" name="Step number 1"/>
           <p:cNvSpPr txBox="1"/>
           <p:nvPr/>
         </p:nvSpPr>
         <p:spPr>
           <a:xfrm>
-            <a:off x="7818120" y="2103120"/>
-            <a:ext cx="640080" cy="548640"/>
+            <a:off x="7818120" y="2148840"/>
+            <a:ext cx="411480" cy="411480"/>
           </a:xfrm>
           <a:prstGeom prst="rect">
             <a:avLst/>
@@ -3090,6 +3115,42 @@
           <a:ln/>
         </p:spPr>
         <p:txBody>
+          <a:bodyPr wrap="square" lIns="0" tIns="0" rIns="0" bIns="0" rtlCol="0" anchor="ctr"/>
+          <a:lstStyle/>
+          <a:p>
+            <a:pPr algn="ctr" indent="0" marL="0">
+              <a:buNone/>
+            </a:pPr>
+            <a:r>
+              <a:rPr lang="en-US" sz="1400" b="1" dirty="0">
+                <a:solidFill>
+                  <a:schemeClr val="bg1"/>
+                </a:solidFill>
+              </a:rPr>
+              <a:t>1</a:t>
+            </a:r>
+            <a:endParaRPr lang="en-US" sz="1400" dirty="0"/>
+          </a:p>
+        </p:txBody>
+      </p:sp>
+      <p:sp>
+        <p:nvSpPr>
+          <p:cNvPr id="9" name="Step text 1"/>
+          <p:cNvSpPr txBox="1"/>
+          <p:nvPr/>
+        </p:nvSpPr>
+        <p:spPr>
+          <a:xfrm>
+            <a:off x="8412480" y="2103120"/>
+            <a:ext cx="3108960" cy="914400"/>
+          </a:xfrm>
+          <a:prstGeom prst="rect">
+            <a:avLst/>
+          </a:prstGeom>
+          <a:noFill/>
+          <a:ln/>
+        </p:spPr>
+        <p:txBody>
           <a:bodyPr wrap="square" lIns="0" tIns="0" rIns="0" bIns="0" rtlCol="0" anchor="t"/>
           <a:lstStyle/>
           <a:p>
@@ -3097,12 +3158,12 @@
               <a:buNone/>
             </a:pPr>
             <a:r>
-              <a:rPr lang="en-US" sz="1400" b="1" dirty="0">
-                <a:solidFill>
-                  <a:schemeClr val="accent1"/>
-                </a:solidFill>
-              </a:rPr>
-              <a:t>0:00</a:t>
+              <a:rPr lang="en-US" sz="1400" dirty="0">
+                <a:solidFill>
+                  <a:schemeClr val="tx1"/>
+                </a:solidFill>
+              </a:rPr>
+              <a:t>Three specialists start together and read the record and the pathway documents</a:t>
             </a:r>
             <a:endParaRPr lang="en-US" sz="1400" dirty="0"/>
           </a:p>
@@ -3110,14 +3171,39 @@
       </p:sp>
       <p:sp>
         <p:nvSpPr>
-          <p:cNvPr id="8" name="Step 1"/>
+          <p:cNvPr id="10" name="Step badge 2"/>
+          <p:cNvSpPr/>
+          <p:nvPr/>
+        </p:nvSpPr>
+        <p:spPr>
+          <a:xfrm>
+            <a:off x="7818120" y="3172968"/>
+            <a:ext cx="411480" cy="411480"/>
+          </a:xfrm>
+          <a:prstGeom prst="ellipse">
+            <a:avLst/>
+          </a:prstGeom>
+          <a:solidFill>
+            <a:schemeClr val="accent1"/>
+          </a:solidFill>
+          <a:ln w="12700">
+            <a:solidFill>
+              <a:schemeClr val="accent1"/>
+            </a:solidFill>
+            <a:prstDash val="solid"/>
+          </a:ln>
+        </p:spPr>
+      </p:sp>
+      <p:sp>
+        <p:nvSpPr>
+          <p:cNvPr id="11" name="Step number 2"/>
           <p:cNvSpPr txBox="1"/>
           <p:nvPr/>
         </p:nvSpPr>
         <p:spPr>
           <a:xfrm>
-            <a:off x="8503920" y="2103120"/>
-            <a:ext cx="3017520" cy="548640"/>
+            <a:off x="7818120" y="3172968"/>
+            <a:ext cx="411480" cy="411480"/>
           </a:xfrm>
           <a:prstGeom prst="rect">
             <a:avLst/>
@@ -3126,6 +3212,42 @@
           <a:ln/>
         </p:spPr>
         <p:txBody>
+          <a:bodyPr wrap="square" lIns="0" tIns="0" rIns="0" bIns="0" rtlCol="0" anchor="ctr"/>
+          <a:lstStyle/>
+          <a:p>
+            <a:pPr algn="ctr" indent="0" marL="0">
+              <a:buNone/>
+            </a:pPr>
+            <a:r>
+              <a:rPr lang="en-US" sz="1400" b="1" dirty="0">
+                <a:solidFill>
+                  <a:schemeClr val="bg1"/>
+                </a:solidFill>
+              </a:rPr>
+              <a:t>2</a:t>
+            </a:r>
+            <a:endParaRPr lang="en-US" sz="1400" dirty="0"/>
+          </a:p>
+        </p:txBody>
+      </p:sp>
+      <p:sp>
+        <p:nvSpPr>
+          <p:cNvPr id="12" name="Step text 2"/>
+          <p:cNvSpPr txBox="1"/>
+          <p:nvPr/>
+        </p:nvSpPr>
+        <p:spPr>
+          <a:xfrm>
+            <a:off x="8412480" y="3127248"/>
+            <a:ext cx="3108960" cy="914400"/>
+          </a:xfrm>
+          <a:prstGeom prst="rect">
+            <a:avLst/>
+          </a:prstGeom>
+          <a:noFill/>
+          <a:ln/>
+        </p:spPr>
+        <p:txBody>
           <a:bodyPr wrap="square" lIns="0" tIns="0" rIns="0" bIns="0" rtlCol="0" anchor="t"/>
           <a:lstStyle/>
           <a:p>
@@ -3138,7 +3260,7 @@
                   <a:schemeClr val="tx1"/>
                 </a:solidFill>
               </a:rPr>
-              <a:t>The case and the oncologist's request</a:t>
+              <a:t>The manager drafts a packet that keeps patient facts, pathway text and inference apart</a:t>
             </a:r>
             <a:endParaRPr lang="en-US" sz="1400" dirty="0"/>
           </a:p>
@@ -3146,14 +3268,39 @@
       </p:sp>
       <p:sp>
         <p:nvSpPr>
-          <p:cNvPr id="9" name="Time 2"/>
+          <p:cNvPr id="13" name="Step badge 3"/>
+          <p:cNvSpPr/>
+          <p:nvPr/>
+        </p:nvSpPr>
+        <p:spPr>
+          <a:xfrm>
+            <a:off x="7818120" y="4197096"/>
+            <a:ext cx="411480" cy="411480"/>
+          </a:xfrm>
+          <a:prstGeom prst="ellipse">
+            <a:avLst/>
+          </a:prstGeom>
+          <a:solidFill>
+            <a:schemeClr val="accent1"/>
+          </a:solidFill>
+          <a:ln w="12700">
+            <a:solidFill>
+              <a:schemeClr val="accent1"/>
+            </a:solidFill>
+            <a:prstDash val="solid"/>
+          </a:ln>
+        </p:spPr>
+      </p:sp>
+      <p:sp>
+        <p:nvSpPr>
+          <p:cNvPr id="14" name="Step number 3"/>
           <p:cNvSpPr txBox="1"/>
           <p:nvPr/>
         </p:nvSpPr>
         <p:spPr>
           <a:xfrm>
-            <a:off x="7818120" y="2743200"/>
-            <a:ext cx="640080" cy="548640"/>
+            <a:off x="7818120" y="4197096"/>
+            <a:ext cx="411480" cy="411480"/>
           </a:xfrm>
           <a:prstGeom prst="rect">
             <a:avLst/>
@@ -3162,6 +3309,42 @@
           <a:ln/>
         </p:spPr>
         <p:txBody>
+          <a:bodyPr wrap="square" lIns="0" tIns="0" rIns="0" bIns="0" rtlCol="0" anchor="ctr"/>
+          <a:lstStyle/>
+          <a:p>
+            <a:pPr algn="ctr" indent="0" marL="0">
+              <a:buNone/>
+            </a:pPr>
+            <a:r>
+              <a:rPr lang="en-US" sz="1400" b="1" dirty="0">
+                <a:solidFill>
+                  <a:schemeClr val="bg1"/>
+                </a:solidFill>
+              </a:rPr>
+              <a:t>3</a:t>
+            </a:r>
+            <a:endParaRPr lang="en-US" sz="1400" dirty="0"/>
+          </a:p>
+        </p:txBody>
+      </p:sp>
+      <p:sp>
+        <p:nvSpPr>
+          <p:cNvPr id="15" name="Step text 3"/>
+          <p:cNvSpPr txBox="1"/>
+          <p:nvPr/>
+        </p:nvSpPr>
+        <p:spPr>
+          <a:xfrm>
+            <a:off x="8412480" y="4151376"/>
+            <a:ext cx="3108960" cy="914400"/>
+          </a:xfrm>
+          <a:prstGeom prst="rect">
+            <a:avLst/>
+          </a:prstGeom>
+          <a:noFill/>
+          <a:ln/>
+        </p:spPr>
+        <p:txBody>
           <a:bodyPr wrap="square" lIns="0" tIns="0" rIns="0" bIns="0" rtlCol="0" anchor="t"/>
           <a:lstStyle/>
           <a:p>
@@ -3169,12 +3352,12 @@
               <a:buNone/>
             </a:pPr>
             <a:r>
-              <a:rPr lang="en-US" sz="1400" b="1" dirty="0">
-                <a:solidFill>
-                  <a:schemeClr val="accent1"/>
-                </a:solidFill>
-              </a:rPr>
-              <a:t>0:30</a:t>
+              <a:rPr lang="en-US" sz="1400" dirty="0">
+                <a:solidFill>
+                  <a:schemeClr val="tx1"/>
+                </a:solidFill>
+              </a:rPr>
+              <a:t>A separate verifier checks every claim against its source</a:t>
             </a:r>
             <a:endParaRPr lang="en-US" sz="1400" dirty="0"/>
           </a:p>
@@ -3182,14 +3365,39 @@
       </p:sp>
       <p:sp>
         <p:nvSpPr>
-          <p:cNvPr id="10" name="Step 2"/>
+          <p:cNvPr id="16" name="Step badge 4"/>
+          <p:cNvSpPr/>
+          <p:nvPr/>
+        </p:nvSpPr>
+        <p:spPr>
+          <a:xfrm>
+            <a:off x="7818120" y="5221224"/>
+            <a:ext cx="411480" cy="411480"/>
+          </a:xfrm>
+          <a:prstGeom prst="ellipse">
+            <a:avLst/>
+          </a:prstGeom>
+          <a:solidFill>
+            <a:schemeClr val="accent1"/>
+          </a:solidFill>
+          <a:ln w="12700">
+            <a:solidFill>
+              <a:schemeClr val="accent1"/>
+            </a:solidFill>
+            <a:prstDash val="solid"/>
+          </a:ln>
+        </p:spPr>
+      </p:sp>
+      <p:sp>
+        <p:nvSpPr>
+          <p:cNvPr id="17" name="Step number 4"/>
           <p:cNvSpPr txBox="1"/>
           <p:nvPr/>
         </p:nvSpPr>
         <p:spPr>
           <a:xfrm>
-            <a:off x="8503920" y="2743200"/>
-            <a:ext cx="3017520" cy="548640"/>
+            <a:off x="7818120" y="5221224"/>
+            <a:ext cx="411480" cy="411480"/>
           </a:xfrm>
           <a:prstGeom prst="rect">
             <a:avLst/>
@@ -3198,6 +3406,42 @@
           <a:ln/>
         </p:spPr>
         <p:txBody>
+          <a:bodyPr wrap="square" lIns="0" tIns="0" rIns="0" bIns="0" rtlCol="0" anchor="ctr"/>
+          <a:lstStyle/>
+          <a:p>
+            <a:pPr algn="ctr" indent="0" marL="0">
+              <a:buNone/>
+            </a:pPr>
+            <a:r>
+              <a:rPr lang="en-US" sz="1400" b="1" dirty="0">
+                <a:solidFill>
+                  <a:schemeClr val="bg1"/>
+                </a:solidFill>
+              </a:rPr>
+              <a:t>4</a:t>
+            </a:r>
+            <a:endParaRPr lang="en-US" sz="1400" dirty="0"/>
+          </a:p>
+        </p:txBody>
+      </p:sp>
+      <p:sp>
+        <p:nvSpPr>
+          <p:cNvPr id="18" name="Step text 4"/>
+          <p:cNvSpPr txBox="1"/>
+          <p:nvPr/>
+        </p:nvSpPr>
+        <p:spPr>
+          <a:xfrm>
+            <a:off x="8412480" y="5175504"/>
+            <a:ext cx="3108960" cy="914400"/>
+          </a:xfrm>
+          <a:prstGeom prst="rect">
+            <a:avLst/>
+          </a:prstGeom>
+          <a:noFill/>
+          <a:ln/>
+        </p:spPr>
+        <p:txBody>
           <a:bodyPr wrap="square" lIns="0" tIns="0" rIns="0" bIns="0" rtlCol="0" anchor="t"/>
           <a:lstStyle/>
           <a:p>
@@ -3210,295 +3454,7 @@
                   <a:schemeClr val="tx1"/>
                 </a:solidFill>
               </a:rPr>
-              <a:t>Specialists read the record through MCP and search the pathways</a:t>
-            </a:r>
-            <a:endParaRPr lang="en-US" sz="1400" dirty="0"/>
-          </a:p>
-        </p:txBody>
-      </p:sp>
-      <p:sp>
-        <p:nvSpPr>
-          <p:cNvPr id="11" name="Time 3"/>
-          <p:cNvSpPr txBox="1"/>
-          <p:nvPr/>
-        </p:nvSpPr>
-        <p:spPr>
-          <a:xfrm>
-            <a:off x="7818120" y="3383280"/>
-            <a:ext cx="640080" cy="548640"/>
-          </a:xfrm>
-          <a:prstGeom prst="rect">
-            <a:avLst/>
-          </a:prstGeom>
-          <a:noFill/>
-          <a:ln/>
-        </p:spPr>
-        <p:txBody>
-          <a:bodyPr wrap="square" lIns="0" tIns="0" rIns="0" bIns="0" rtlCol="0" anchor="t"/>
-          <a:lstStyle/>
-          <a:p>
-            <a:pPr indent="0" marL="0">
-              <a:buNone/>
-            </a:pPr>
-            <a:r>
-              <a:rPr lang="en-US" sz="1400" b="1" dirty="0">
-                <a:solidFill>
-                  <a:schemeClr val="accent1"/>
-                </a:solidFill>
-              </a:rPr>
-              <a:t>1:30</a:t>
-            </a:r>
-            <a:endParaRPr lang="en-US" sz="1400" dirty="0"/>
-          </a:p>
-        </p:txBody>
-      </p:sp>
-      <p:sp>
-        <p:nvSpPr>
-          <p:cNvPr id="12" name="Step 3"/>
-          <p:cNvSpPr txBox="1"/>
-          <p:nvPr/>
-        </p:nvSpPr>
-        <p:spPr>
-          <a:xfrm>
-            <a:off x="8503920" y="3383280"/>
-            <a:ext cx="3017520" cy="548640"/>
-          </a:xfrm>
-          <a:prstGeom prst="rect">
-            <a:avLst/>
-          </a:prstGeom>
-          <a:noFill/>
-          <a:ln/>
-        </p:spPr>
-        <p:txBody>
-          <a:bodyPr wrap="square" lIns="0" tIns="0" rIns="0" bIns="0" rtlCol="0" anchor="t"/>
-          <a:lstStyle/>
-          <a:p>
-            <a:pPr indent="0" marL="0">
-              <a:buNone/>
-            </a:pPr>
-            <a:r>
-              <a:rPr lang="en-US" sz="1400" dirty="0">
-                <a:solidFill>
-                  <a:schemeClr val="tx1"/>
-                </a:solidFill>
-              </a:rPr>
-              <a:t>The draft keeps patient facts, pathway text and inference apart</a:t>
-            </a:r>
-            <a:endParaRPr lang="en-US" sz="1400" dirty="0"/>
-          </a:p>
-        </p:txBody>
-      </p:sp>
-      <p:sp>
-        <p:nvSpPr>
-          <p:cNvPr id="13" name="Time 4"/>
-          <p:cNvSpPr txBox="1"/>
-          <p:nvPr/>
-        </p:nvSpPr>
-        <p:spPr>
-          <a:xfrm>
-            <a:off x="7818120" y="4023360"/>
-            <a:ext cx="640080" cy="548640"/>
-          </a:xfrm>
-          <a:prstGeom prst="rect">
-            <a:avLst/>
-          </a:prstGeom>
-          <a:noFill/>
-          <a:ln/>
-        </p:spPr>
-        <p:txBody>
-          <a:bodyPr wrap="square" lIns="0" tIns="0" rIns="0" bIns="0" rtlCol="0" anchor="t"/>
-          <a:lstStyle/>
-          <a:p>
-            <a:pPr indent="0" marL="0">
-              <a:buNone/>
-            </a:pPr>
-            <a:r>
-              <a:rPr lang="en-US" sz="1400" b="1" dirty="0">
-                <a:solidFill>
-                  <a:schemeClr val="accent1"/>
-                </a:solidFill>
-              </a:rPr>
-              <a:t>2:30</a:t>
-            </a:r>
-            <a:endParaRPr lang="en-US" sz="1400" dirty="0"/>
-          </a:p>
-        </p:txBody>
-      </p:sp>
-      <p:sp>
-        <p:nvSpPr>
-          <p:cNvPr id="14" name="Step 4"/>
-          <p:cNvSpPr txBox="1"/>
-          <p:nvPr/>
-        </p:nvSpPr>
-        <p:spPr>
-          <a:xfrm>
-            <a:off x="8503920" y="4023360"/>
-            <a:ext cx="3017520" cy="548640"/>
-          </a:xfrm>
-          <a:prstGeom prst="rect">
-            <a:avLst/>
-          </a:prstGeom>
-          <a:noFill/>
-          <a:ln/>
-        </p:spPr>
-        <p:txBody>
-          <a:bodyPr wrap="square" lIns="0" tIns="0" rIns="0" bIns="0" rtlCol="0" anchor="t"/>
-          <a:lstStyle/>
-          <a:p>
-            <a:pPr indent="0" marL="0">
-              <a:buNone/>
-            </a:pPr>
-            <a:r>
-              <a:rPr lang="en-US" sz="1400" dirty="0">
-                <a:solidFill>
-                  <a:schemeClr val="tx1"/>
-                </a:solidFill>
-              </a:rPr>
-              <a:t>The verifier flags problems; the HER2 conflict is shown</a:t>
-            </a:r>
-            <a:endParaRPr lang="en-US" sz="1400" dirty="0"/>
-          </a:p>
-        </p:txBody>
-      </p:sp>
-      <p:sp>
-        <p:nvSpPr>
-          <p:cNvPr id="15" name="Time 5"/>
-          <p:cNvSpPr txBox="1"/>
-          <p:nvPr/>
-        </p:nvSpPr>
-        <p:spPr>
-          <a:xfrm>
-            <a:off x="7818120" y="4663440"/>
-            <a:ext cx="640080" cy="548640"/>
-          </a:xfrm>
-          <a:prstGeom prst="rect">
-            <a:avLst/>
-          </a:prstGeom>
-          <a:noFill/>
-          <a:ln/>
-        </p:spPr>
-        <p:txBody>
-          <a:bodyPr wrap="square" lIns="0" tIns="0" rIns="0" bIns="0" rtlCol="0" anchor="t"/>
-          <a:lstStyle/>
-          <a:p>
-            <a:pPr indent="0" marL="0">
-              <a:buNone/>
-            </a:pPr>
-            <a:r>
-              <a:rPr lang="en-US" sz="1400" b="1" dirty="0">
-                <a:solidFill>
-                  <a:schemeClr val="accent1"/>
-                </a:solidFill>
-              </a:rPr>
-              <a:t>3:30</a:t>
-            </a:r>
-            <a:endParaRPr lang="en-US" sz="1400" dirty="0"/>
-          </a:p>
-        </p:txBody>
-      </p:sp>
-      <p:sp>
-        <p:nvSpPr>
-          <p:cNvPr id="16" name="Step 5"/>
-          <p:cNvSpPr txBox="1"/>
-          <p:nvPr/>
-        </p:nvSpPr>
-        <p:spPr>
-          <a:xfrm>
-            <a:off x="8503920" y="4663440"/>
-            <a:ext cx="3017520" cy="548640"/>
-          </a:xfrm>
-          <a:prstGeom prst="rect">
-            <a:avLst/>
-          </a:prstGeom>
-          <a:noFill/>
-          <a:ln/>
-        </p:spPr>
-        <p:txBody>
-          <a:bodyPr wrap="square" lIns="0" tIns="0" rIns="0" bIns="0" rtlCol="0" anchor="t"/>
-          <a:lstStyle/>
-          <a:p>
-            <a:pPr indent="0" marL="0">
-              <a:buNone/>
-            </a:pPr>
-            <a:r>
-              <a:rPr lang="en-US" sz="1400" dirty="0">
-                <a:solidFill>
-                  <a:schemeClr val="tx1"/>
-                </a:solidFill>
-              </a:rPr>
-              <a:t>The oncologist reviews and approves</a:t>
-            </a:r>
-            <a:endParaRPr lang="en-US" sz="1400" dirty="0"/>
-          </a:p>
-        </p:txBody>
-      </p:sp>
-      <p:sp>
-        <p:nvSpPr>
-          <p:cNvPr id="17" name="Time 6"/>
-          <p:cNvSpPr txBox="1"/>
-          <p:nvPr/>
-        </p:nvSpPr>
-        <p:spPr>
-          <a:xfrm>
-            <a:off x="7818120" y="5303520"/>
-            <a:ext cx="640080" cy="548640"/>
-          </a:xfrm>
-          <a:prstGeom prst="rect">
-            <a:avLst/>
-          </a:prstGeom>
-          <a:noFill/>
-          <a:ln/>
-        </p:spPr>
-        <p:txBody>
-          <a:bodyPr wrap="square" lIns="0" tIns="0" rIns="0" bIns="0" rtlCol="0" anchor="t"/>
-          <a:lstStyle/>
-          <a:p>
-            <a:pPr indent="0" marL="0">
-              <a:buNone/>
-            </a:pPr>
-            <a:r>
-              <a:rPr lang="en-US" sz="1400" b="1" dirty="0">
-                <a:solidFill>
-                  <a:schemeClr val="accent1"/>
-                </a:solidFill>
-              </a:rPr>
-              <a:t>4:15</a:t>
-            </a:r>
-            <a:endParaRPr lang="en-US" sz="1400" dirty="0"/>
-          </a:p>
-        </p:txBody>
-      </p:sp>
-      <p:sp>
-        <p:nvSpPr>
-          <p:cNvPr id="18" name="Step 6"/>
-          <p:cNvSpPr txBox="1"/>
-          <p:nvPr/>
-        </p:nvSpPr>
-        <p:spPr>
-          <a:xfrm>
-            <a:off x="8503920" y="5303520"/>
-            <a:ext cx="3017520" cy="548640"/>
-          </a:xfrm>
-          <a:prstGeom prst="rect">
-            <a:avLst/>
-          </a:prstGeom>
-          <a:noFill/>
-          <a:ln/>
-        </p:spPr>
-        <p:txBody>
-          <a:bodyPr wrap="square" lIns="0" tIns="0" rIns="0" bIns="0" rtlCol="0" anchor="t"/>
-          <a:lstStyle/>
-          <a:p>
-            <a:pPr indent="0" marL="0">
-              <a:buNone/>
-            </a:pPr>
-            <a:r>
-              <a:rPr lang="en-US" sz="1400" dirty="0">
-                <a:solidFill>
-                  <a:schemeClr val="tx1"/>
-                </a:solidFill>
-              </a:rPr>
-              <a:t>Value and next steps</a:t>
+              <a:t>The run pauses. Nothing is saved until the oncologist approves</a:t>
             </a:r>
             <a:endParaRPr lang="en-US" sz="1400" dirty="0"/>
           </a:p>
@@ -3619,8 +3575,8 @@
           <p:nvPr/>
         </p:nvGraphicFramePr>
         <p:xfrm>
-          <a:off x="548640" y="1463040"/>
-          <a:ext cx="5669280" cy="4114800"/>
+          <a:off x="548640" y="1371600"/>
+          <a:ext cx="5120640" cy="4206240"/>
         </p:xfrm>
         <a:graphic xmlns:a="http://schemas.openxmlformats.org/drawingml/2006/main">
           <a:graphicData uri="http://schemas.openxmlformats.org/drawingml/2006/chart">
@@ -3636,12 +3592,12 @@
         </p:nvSpPr>
         <p:spPr>
           <a:xfrm>
-            <a:off x="6583680" y="1463040"/>
-            <a:ext cx="5074920" cy="1280160"/>
+            <a:off x="6035040" y="1371600"/>
+            <a:ext cx="5623560" cy="1005840"/>
           </a:xfrm>
           <a:prstGeom prst="roundRect">
             <a:avLst>
-              <a:gd name="adj" fmla="val 8571"/>
+              <a:gd name="adj" fmla="val 10909"/>
             </a:avLst>
           </a:prstGeom>
           <a:solidFill>
@@ -3663,8 +3619,8 @@
         </p:nvSpPr>
         <p:spPr>
           <a:xfrm>
-            <a:off x="6812280" y="1572768"/>
-            <a:ext cx="4617720" cy="502920"/>
+            <a:off x="6263640" y="1444752"/>
+            <a:ext cx="5166360" cy="457200"/>
           </a:xfrm>
           <a:prstGeom prst="rect">
             <a:avLst/>
@@ -3680,14 +3636,14 @@
               <a:buNone/>
             </a:pPr>
             <a:r>
-              <a:rPr lang="en-US" sz="2400" b="1" dirty="0">
+              <a:rPr lang="en-US" sz="2200" b="1" dirty="0">
                 <a:solidFill>
                   <a:schemeClr val="accent1"/>
                 </a:solidFill>
               </a:rPr>
-              <a:t>About 33 hours a month</a:t>
-            </a:r>
-            <a:endParaRPr lang="en-US" sz="2400" dirty="0"/>
+              <a:t>88 seconds</a:t>
+            </a:r>
+            <a:endParaRPr lang="en-US" sz="2200" dirty="0"/>
           </a:p>
         </p:txBody>
       </p:sp>
@@ -3699,8 +3655,8 @@
         </p:nvSpPr>
         <p:spPr>
           <a:xfrm>
-            <a:off x="6812280" y="2103120"/>
-            <a:ext cx="4617720" cy="548640"/>
+            <a:off x="6263640" y="1901952"/>
+            <a:ext cx="5166360" cy="411480"/>
           </a:xfrm>
           <a:prstGeom prst="rect">
             <a:avLst/>
@@ -3721,7 +3677,7 @@
                   <a:schemeClr val="tx1"/>
                 </a:solidFill>
               </a:rPr>
-              <a:t>of clinician and navigator time, at 40 cases a month</a:t>
+              <a:t>of agent work per case, measured over 10 runs</a:t>
             </a:r>
             <a:endParaRPr lang="en-US" sz="1400" dirty="0"/>
           </a:p>
@@ -3735,12 +3691,12 @@
         </p:nvSpPr>
         <p:spPr>
           <a:xfrm>
-            <a:off x="6583680" y="2880360"/>
-            <a:ext cx="5074920" cy="1280160"/>
+            <a:off x="6035040" y="2468880"/>
+            <a:ext cx="5623560" cy="1005840"/>
           </a:xfrm>
           <a:prstGeom prst="roundRect">
             <a:avLst>
-              <a:gd name="adj" fmla="val 8571"/>
+              <a:gd name="adj" fmla="val 10909"/>
             </a:avLst>
           </a:prstGeom>
           <a:solidFill>
@@ -3762,8 +3718,8 @@
         </p:nvSpPr>
         <p:spPr>
           <a:xfrm>
-            <a:off x="6812280" y="2990088"/>
-            <a:ext cx="4617720" cy="502920"/>
+            <a:off x="6263640" y="2542032"/>
+            <a:ext cx="5166360" cy="457200"/>
           </a:xfrm>
           <a:prstGeom prst="rect">
             <a:avLst/>
@@ -3779,14 +3735,14 @@
               <a:buNone/>
             </a:pPr>
             <a:r>
-              <a:rPr lang="en-US" sz="2400" b="1" dirty="0">
+              <a:rPr lang="en-US" sz="2200" b="1" dirty="0">
                 <a:solidFill>
                   <a:schemeClr val="accent1"/>
                 </a:solidFill>
               </a:rPr>
-              <a:t>About $4,000 a month</a:t>
-            </a:r>
-            <a:endParaRPr lang="en-US" sz="2400" dirty="0"/>
+              <a:t>About 10 cents</a:t>
+            </a:r>
+            <a:endParaRPr lang="en-US" sz="2200" dirty="0"/>
           </a:p>
         </p:txBody>
       </p:sp>
@@ -3798,8 +3754,8 @@
         </p:nvSpPr>
         <p:spPr>
           <a:xfrm>
-            <a:off x="6812280" y="3520440"/>
-            <a:ext cx="4617720" cy="548640"/>
+            <a:off x="6263640" y="2999232"/>
+            <a:ext cx="5166360" cy="411480"/>
           </a:xfrm>
           <a:prstGeom prst="rect">
             <a:avLst/>
@@ -3820,7 +3776,7 @@
                   <a:schemeClr val="tx1"/>
                 </a:solidFill>
               </a:rPr>
-              <a:t>at a blended $120 an hour. Small next to the other benefits</a:t>
+              <a:t>of model cost per case at list prices, measured</a:t>
             </a:r>
             <a:endParaRPr lang="en-US" sz="1400" dirty="0"/>
           </a:p>
@@ -3834,12 +3790,12 @@
         </p:nvSpPr>
         <p:spPr>
           <a:xfrm>
-            <a:off x="6583680" y="4297680"/>
-            <a:ext cx="5074920" cy="1280160"/>
+            <a:off x="6035040" y="3566160"/>
+            <a:ext cx="5623560" cy="1005840"/>
           </a:xfrm>
           <a:prstGeom prst="roundRect">
             <a:avLst>
-              <a:gd name="adj" fmla="val 8571"/>
+              <a:gd name="adj" fmla="val 10909"/>
             </a:avLst>
           </a:prstGeom>
           <a:solidFill>
@@ -3861,8 +3817,8 @@
         </p:nvSpPr>
         <p:spPr>
           <a:xfrm>
-            <a:off x="6812280" y="4407408"/>
-            <a:ext cx="4617720" cy="502920"/>
+            <a:off x="6263640" y="3639312"/>
+            <a:ext cx="5166360" cy="457200"/>
           </a:xfrm>
           <a:prstGeom prst="rect">
             <a:avLst/>
@@ -3878,14 +3834,14 @@
               <a:buNone/>
             </a:pPr>
             <a:r>
-              <a:rPr lang="en-US" sz="2400" b="1" dirty="0">
+              <a:rPr lang="en-US" sz="2200" b="1" dirty="0">
                 <a:solidFill>
                   <a:schemeClr val="accent1"/>
                 </a:solidFill>
               </a:rPr>
-              <a:t>Fewer missed conflicts</a:t>
-            </a:r>
-            <a:endParaRPr lang="en-US" sz="2400" dirty="0"/>
+              <a:t>6 of 6 checks</a:t>
+            </a:r>
+            <a:endParaRPr lang="en-US" sz="2200" dirty="0"/>
           </a:p>
         </p:txBody>
       </p:sp>
@@ -3897,8 +3853,8 @@
         </p:nvSpPr>
         <p:spPr>
           <a:xfrm>
-            <a:off x="6812280" y="4937760"/>
-            <a:ext cx="4617720" cy="548640"/>
+            <a:off x="6263640" y="4096512"/>
+            <a:ext cx="5166360" cy="411480"/>
           </a:xfrm>
           <a:prstGeom prst="rect">
             <a:avLst/>
@@ -3919,7 +3875,7 @@
                   <a:schemeClr val="tx1"/>
                 </a:solidFill>
               </a:rPr>
-              <a:t>to measure: sources that disagree, caught before the meeting</a:t>
+              <a:t>on the planted problems passed in all 10 runs</a:t>
             </a:r>
             <a:endParaRPr lang="en-US" sz="1400" dirty="0"/>
           </a:p>
@@ -3927,14 +3883,41 @@
       </p:sp>
       <p:sp>
         <p:nvSpPr>
-          <p:cNvPr id="13" name="Value footnote"/>
+          <p:cNvPr id="13" name="Value card 4"/>
+          <p:cNvSpPr/>
+          <p:nvPr/>
+        </p:nvSpPr>
+        <p:spPr>
+          <a:xfrm>
+            <a:off x="6035040" y="4663440"/>
+            <a:ext cx="5623560" cy="1005840"/>
+          </a:xfrm>
+          <a:prstGeom prst="roundRect">
+            <a:avLst>
+              <a:gd name="adj" fmla="val 10909"/>
+            </a:avLst>
+          </a:prstGeom>
+          <a:solidFill>
+            <a:schemeClr val="bg2"/>
+          </a:solidFill>
+          <a:ln w="12700">
+            <a:solidFill>
+              <a:schemeClr val="bg2"/>
+            </a:solidFill>
+            <a:prstDash val="solid"/>
+          </a:ln>
+        </p:spPr>
+      </p:sp>
+      <p:sp>
+        <p:nvSpPr>
+          <p:cNvPr id="14" name="Value 4"/>
           <p:cNvSpPr txBox="1"/>
           <p:nvPr/>
         </p:nvSpPr>
         <p:spPr>
           <a:xfrm>
-            <a:off x="548640" y="5852160"/>
-            <a:ext cx="11064240" cy="457200"/>
+            <a:off x="6263640" y="4736592"/>
+            <a:ext cx="5166360" cy="457200"/>
           </a:xfrm>
           <a:prstGeom prst="rect">
             <a:avLst/>
@@ -3950,12 +3933,84 @@
               <a:buNone/>
             </a:pPr>
             <a:r>
+              <a:rPr lang="en-US" sz="2200" b="1" dirty="0">
+                <a:solidFill>
+                  <a:schemeClr val="accent4"/>
+                </a:solidFill>
+              </a:rPr>
+              <a:t>About 33 hours a month</a:t>
+            </a:r>
+            <a:endParaRPr lang="en-US" sz="2200" dirty="0"/>
+          </a:p>
+        </p:txBody>
+      </p:sp>
+      <p:sp>
+        <p:nvSpPr>
+          <p:cNvPr id="15" name="Value label 4"/>
+          <p:cNvSpPr txBox="1"/>
+          <p:nvPr/>
+        </p:nvSpPr>
+        <p:spPr>
+          <a:xfrm>
+            <a:off x="6263640" y="5193792"/>
+            <a:ext cx="5166360" cy="411480"/>
+          </a:xfrm>
+          <a:prstGeom prst="rect">
+            <a:avLst/>
+          </a:prstGeom>
+          <a:noFill/>
+          <a:ln/>
+        </p:spPr>
+        <p:txBody>
+          <a:bodyPr wrap="square" lIns="0" tIns="0" rIns="0" bIns="0" rtlCol="0" anchor="t"/>
+          <a:lstStyle/>
+          <a:p>
+            <a:pPr indent="0" marL="0">
+              <a:buNone/>
+            </a:pPr>
+            <a:r>
+              <a:rPr lang="en-US" sz="1400" dirty="0">
+                <a:solidFill>
+                  <a:schemeClr val="tx1"/>
+                </a:solidFill>
+              </a:rPr>
+              <a:t>of clinician time saved (assumed: 40 cases, 75 down to 25 min)</a:t>
+            </a:r>
+            <a:endParaRPr lang="en-US" sz="1400" dirty="0"/>
+          </a:p>
+        </p:txBody>
+      </p:sp>
+      <p:sp>
+        <p:nvSpPr>
+          <p:cNvPr id="16" name="Value footnote"/>
+          <p:cNvSpPr txBox="1"/>
+          <p:nvPr/>
+        </p:nvSpPr>
+        <p:spPr>
+          <a:xfrm>
+            <a:off x="548640" y="5806440"/>
+            <a:ext cx="11064240" cy="502920"/>
+          </a:xfrm>
+          <a:prstGeom prst="rect">
+            <a:avLst/>
+          </a:prstGeom>
+          <a:noFill/>
+          <a:ln/>
+        </p:spPr>
+        <p:txBody>
+          <a:bodyPr wrap="square" lIns="0" tIns="0" rIns="0" bIns="0" rtlCol="0" anchor="ctr"/>
+          <a:lstStyle/>
+          <a:p>
+            <a:pPr indent="0" marL="0">
+              <a:buNone/>
+            </a:pPr>
+            <a:r>
               <a:rPr lang="en-US" sz="1200" dirty="0">
                 <a:solidFill>
                   <a:schemeClr val="accent4"/>
                 </a:solidFill>
               </a:rPr>
-              <a:t>Assumptions are illustrative and editable in the value model spreadsheet. A pilot would replace them with measured times.</a:t>
+              <a:t>Time and cost are measured on the synthetic case. Hours saved is an assumption, editable in the value model. A pilot would measure real preparation times.</a:t>
             </a:r>
             <a:endParaRPr lang="en-US" sz="1200" dirty="0"/>
           </a:p>

</xml_diff>

<commit_message>
Rename manager to case coordinator, add follow-up questions and record viewer
</commit_message>
<xml_diff>
--- a/deck/case-prep-deck.pptx
+++ b/deck/case-prep-deck.pptx
@@ -111,18 +111,18 @@
   <p:extLst>
     <p:ext uri="{521415D9-36F7-43E2-AB2F-B90AF26B5E84}">
       <p14:sectionLst xmlns:p14="http://schemas.microsoft.com/office/powerpoint/2010/main">
-        <p14:section name="Setup" id="{01c15aa2-99b0-e163-f5e0-88f47e305dcb}">
+        <p14:section name="Setup" id="{6af515ad-591f-6cc9-b37c-7dd74c826212}">
           <p14:sldIdLst>
             <p14:sldId id="256"/>
             <p14:sldId id="257"/>
           </p14:sldIdLst>
         </p14:section>
-        <p14:section name="Demo" id="{5e64b9d8-13fd-3871-294b-dffba0f733d9}">
+        <p14:section name="Demo" id="{bcb3dd28-f022-d1ab-5fc5-c2253136e0c1}">
           <p14:sldIdLst>
             <p14:sldId id="258"/>
           </p14:sldIdLst>
         </p14:section>
-        <p14:section name="Value" id="{7ae744a5-5c83-50b4-fcfc-866318b78822}">
+        <p14:section name="Value" id="{c2773714-ac24-52eb-abaa-f39cbb7ddf75}">
           <p14:sldIdLst>
             <p14:sldId id="259"/>
             <p14:sldId id="260"/>
@@ -995,7 +995,7 @@
           <a:p>
             <a:r>
               <a:rPr lang="en-US" dirty="0"/>
-              <a:t>This slide is the OpenAI side. A manager agent on gpt-6.1-sol starts three specialists together. The patient data and history specialists read the record through an MCP server. The evidence specialist searches the pathway documents with File Search and looks up PubMed. The specialists use gpt-6.1-terra, which is faster and cheaper, because they are reading and extracting. A separate verifier checks the draft. Then the run pauses for the oncologist. Everything runs in the customer's own AWS account; only model calls and pathway search go to OpenAI.</a:t>
+              <a:t>This slide is the OpenAI side. A case coordinator agent on gpt-6.1-sol starts three specialists together. The patient data and history specialists read the record through an MCP server. The evidence specialist searches the pathway documents with File Search and looks up PubMed. The specialists use gpt-6.1-terra, which is faster and cheaper, because they are reading and extracting. A separate verifier checks the draft. Then the run pauses for the oncologist. Everything runs in the customer's own AWS account; only model calls and pathway search go to OpenAI.</a:t>
             </a:r>
             <a:endParaRPr lang="en-US" dirty="0"/>
           </a:p>
@@ -2835,7 +2835,7 @@
                   <a:schemeClr val="bg1"/>
                 </a:solidFill>
               </a:rPr>
-              <a:t>Responses API for the model calls, Agents SDK for the manager and specialists, File Search for pathway documents, MCP for the patient record, tracing for review.</a:t>
+              <a:t>Responses API for the model calls, Agents SDK for the case coordinator and specialists, File Search for pathway documents, MCP for the patient record, tracing for review.</a:t>
             </a:r>
             <a:endParaRPr lang="en-US" sz="1600" dirty="0"/>
           </a:p>
@@ -2951,7 +2951,7 @@
       </p:sp>
       <p:pic>
         <p:nvPicPr>
-          <p:cNvPr id="3" name="Agent graph" descr="Agent graph: the oncologist's request goes to a manager agent, which starts three specialists together (patient data, clinical history, evidence). A verifier checks the draft, a clinician approves, and the note is saved with an audit trail.">    </p:cNvPr>
+          <p:cNvPr id="3" name="Agent graph" descr="Agent graph: the oncologist's request goes to a case coordinator agent, which starts three specialists together (patient data, clinical history, evidence). A verifier checks the draft, a clinician approves, and the note is saved with an audit trail.">    </p:cNvPr>
           <p:cNvPicPr>
             <a:picLocks noChangeAspect="1"/>
           </p:cNvPicPr>
@@ -3260,7 +3260,7 @@
                   <a:schemeClr val="tx1"/>
                 </a:solidFill>
               </a:rPr>
-              <a:t>The manager drafts a packet that keeps patient facts, pathway text and inference apart</a:t>
+              <a:t>The coordinator drafts a packet that keeps patient facts, pathway text and inference apart</a:t>
             </a:r>
             <a:endParaRPr lang="en-US" sz="1400" dirty="0"/>
           </a:p>

</xml_diff>

<commit_message>
Rename pathway documents to Oncology Care Guidelines
</commit_message>
<xml_diff>
--- a/deck/case-prep-deck.pptx
+++ b/deck/case-prep-deck.pptx
@@ -111,18 +111,18 @@
   <p:extLst>
     <p:ext uri="{521415D9-36F7-43E2-AB2F-B90AF26B5E84}">
       <p14:sectionLst xmlns:p14="http://schemas.microsoft.com/office/powerpoint/2010/main">
-        <p14:section name="Setup" id="{6af515ad-591f-6cc9-b37c-7dd74c826212}">
+        <p14:section name="Setup" id="{90cb8859-4e12-f93f-787d-a4b98ab76abb}">
           <p14:sldIdLst>
             <p14:sldId id="256"/>
             <p14:sldId id="257"/>
           </p14:sldIdLst>
         </p14:section>
-        <p14:section name="Demo" id="{bcb3dd28-f022-d1ab-5fc5-c2253136e0c1}">
+        <p14:section name="Demo" id="{39052ee6-b69e-9dd9-f457-5f8171ce9999}">
           <p14:sldIdLst>
             <p14:sldId id="258"/>
           </p14:sldIdLst>
         </p14:section>
-        <p14:section name="Value" id="{c2773714-ac24-52eb-abaa-f39cbb7ddf75}">
+        <p14:section name="Value" id="{7c68f49b-e8ed-b8ba-f956-11e80da51565}">
           <p14:sldIdLst>
             <p14:sldId id="259"/>
             <p14:sldId id="260"/>
@@ -995,7 +995,7 @@
           <a:p>
             <a:r>
               <a:rPr lang="en-US" dirty="0"/>
-              <a:t>This slide is the OpenAI side. A case coordinator agent on gpt-6.1-sol starts three specialists together. The patient data and history specialists read the record through an MCP server. The evidence specialist searches the pathway documents with File Search and looks up PubMed. The specialists use gpt-6.1-terra, which is faster and cheaper, because they are reading and extracting. A separate verifier checks the draft. Then the run pauses for the oncologist. Everything runs in the customer's own AWS account; only model calls and pathway search go to OpenAI.</a:t>
+              <a:t>This slide is the OpenAI side. A case coordinator agent on gpt-6.1-sol starts three specialists together. The patient data and history specialists read the record through an MCP server. The evidence specialist searches the Oncology Care Guidelines with File Search and looks up PubMed. The specialists use gpt-6.1-terra, which is faster and cheaper, because they are reading and extracting. A separate verifier checks the draft. Then the run pauses for the oncologist. Everything runs in the customer's own AWS account; only model calls and the guideline search go to OpenAI.</a:t>
             </a:r>
             <a:endParaRPr lang="en-US" dirty="0"/>
           </a:p>
@@ -1083,7 +1083,7 @@
           <a:p>
             <a:r>
               <a:rPr lang="en-US" dirty="0"/>
-              <a:t>Separate measured from assumed. Measured on the synthetic case: about 88 seconds of agent work and under ten cents of model cost per case, and the checks on the planted problems passed in every one of ten runs. Assumed: forty cases a month and preparation dropping from seventy-five minutes to twenty-five, which gives about thirty-three hours a month. The dollar value of that time is modest. The bigger reason is catching conflicts before the meeting, which a pilot would measure.</a:t>
+              <a:t>Separate measured from assumed. Measured on the synthetic case: about 88 seconds of agent work and under ten cents of model cost per case, and 59 of 60 checks on the planted problems passed across ten runs. The one miss was a run that did not mention the old bone density scan. Assumed: forty cases a month and preparation dropping from seventy-five minutes to twenty-five, which gives about thirty-three hours a month. The dollar value of that time is modest. The bigger reason is catching conflicts before the meeting, which a pilot would measure.</a:t>
             </a:r>
             <a:endParaRPr lang="en-US" dirty="0"/>
           </a:p>
@@ -1960,7 +1960,7 @@
                   <a:schemeClr val="bg1"/>
                 </a:solidFill>
               </a:rPr>
-              <a:t>For each case, someone reads pathology, imaging, genomics, clinic notes and the problem list in separate places, then checks the institution's treatment pathway. It is slow, and a disagreement between two sources is easy to miss.</a:t>
+              <a:t>For each case, someone reads pathology, imaging, genomics, clinic notes and the problem list in separate places, then checks the institution's Oncology Care Guidelines. It is slow, and a disagreement between two sources is easy to miss.</a:t>
             </a:r>
             <a:endParaRPr lang="en-US" sz="1800" dirty="0"/>
           </a:p>
@@ -2543,7 +2543,7 @@
                   <a:schemeClr val="tx1"/>
                 </a:solidFill>
               </a:rPr>
-              <a:t>Look up the current treatment pathway</a:t>
+              <a:t>Look up the current Oncology Care Guidelines</a:t>
             </a:r>
             <a:endParaRPr lang="en-US" sz="1600" dirty="0"/>
           </a:p>
@@ -2704,7 +2704,7 @@
                   <a:schemeClr val="tx1"/>
                 </a:solidFill>
               </a:rPr>
-              <a:t>Specialists read each record and the pathway documents</a:t>
+              <a:t>Specialists read each record and the Oncology Care Guidelines</a:t>
             </a:r>
             <a:endParaRPr lang="en-US" sz="1600" dirty="0"/>
           </a:p>
@@ -2723,7 +2723,7 @@
                   <a:schemeClr val="tx1"/>
                 </a:solidFill>
               </a:rPr>
-              <a:t>A draft lists facts, pathway text and inference separately</a:t>
+              <a:t>A draft lists facts, guideline text and inference separately</a:t>
             </a:r>
             <a:endParaRPr lang="en-US" sz="1600" dirty="0"/>
           </a:p>
@@ -2835,7 +2835,7 @@
                   <a:schemeClr val="bg1"/>
                 </a:solidFill>
               </a:rPr>
-              <a:t>Responses API for the model calls, Agents SDK for the case coordinator and specialists, File Search for pathway documents, MCP for the patient record, tracing for review.</a:t>
+              <a:t>Responses API for the model calls, Agents SDK for the case coordinator and specialists, File Search for the Oncology Care Guidelines, MCP for the patient record, tracing for review.</a:t>
             </a:r>
             <a:endParaRPr lang="en-US" sz="1600" dirty="0"/>
           </a:p>
@@ -3163,7 +3163,7 @@
                   <a:schemeClr val="tx1"/>
                 </a:solidFill>
               </a:rPr>
-              <a:t>Three specialists start together and read the record and the pathway documents</a:t>
+              <a:t>Three specialists start together and read the record and the Oncology Care Guidelines</a:t>
             </a:r>
             <a:endParaRPr lang="en-US" sz="1400" dirty="0"/>
           </a:p>
@@ -3260,7 +3260,7 @@
                   <a:schemeClr val="tx1"/>
                 </a:solidFill>
               </a:rPr>
-              <a:t>The coordinator drafts a packet that keeps patient facts, pathway text and inference apart</a:t>
+              <a:t>The coordinator drafts a packet that keeps patient facts, guideline text and inference apart</a:t>
             </a:r>
             <a:endParaRPr lang="en-US" sz="1400" dirty="0"/>
           </a:p>
@@ -3839,7 +3839,7 @@
                   <a:schemeClr val="accent1"/>
                 </a:solidFill>
               </a:rPr>
-              <a:t>6 of 6 checks</a:t>
+              <a:t>59 of 60 checks</a:t>
             </a:r>
             <a:endParaRPr lang="en-US" sz="2200" dirty="0"/>
           </a:p>
@@ -3875,7 +3875,7 @@
                   <a:schemeClr val="tx1"/>
                 </a:solidFill>
               </a:rPr>
-              <a:t>on the planted problems passed in all 10 runs</a:t>
+              <a:t>on the planted problems passed across 10 runs</a:t>
             </a:r>
             <a:endParaRPr lang="en-US" sz="1400" dirty="0"/>
           </a:p>

</xml_diff>

<commit_message>
Multi-site agenda with four cases, similar past cases, identifier masking, per-case evaluation
</commit_message>
<xml_diff>
--- a/deck/case-prep-deck.pptx
+++ b/deck/case-prep-deck.pptx
@@ -111,18 +111,18 @@
   <p:extLst>
     <p:ext uri="{521415D9-36F7-43E2-AB2F-B90AF26B5E84}">
       <p14:sectionLst xmlns:p14="http://schemas.microsoft.com/office/powerpoint/2010/main">
-        <p14:section name="Setup" id="{90cb8859-4e12-f93f-787d-a4b98ab76abb}">
+        <p14:section name="Setup" id="{884a89ed-3ae8-e9cd-d439-9c00211be9b7}">
           <p14:sldIdLst>
             <p14:sldId id="256"/>
             <p14:sldId id="257"/>
           </p14:sldIdLst>
         </p14:section>
-        <p14:section name="Demo" id="{39052ee6-b69e-9dd9-f457-5f8171ce9999}">
+        <p14:section name="Demo" id="{cdebe692-9b56-0106-f58e-a3e86a942582}">
           <p14:sldIdLst>
             <p14:sldId id="258"/>
           </p14:sldIdLst>
         </p14:section>
-        <p14:section name="Value" id="{7c68f49b-e8ed-b8ba-f956-11e80da51565}">
+        <p14:section name="Value" id="{336378a6-9236-846d-b5d3-4f415ca43a12}">
           <p14:sldIdLst>
             <p14:sldId id="259"/>
             <p14:sldId id="260"/>
@@ -819,7 +819,7 @@
           <a:p>
             <a:r>
               <a:rPr lang="en-US" dirty="0"/>
-              <a:t>Introduce the customer and the two users. The point is not that charts are hard to read. It is that the reviewer has to look in five places and compare them by eye. In this demo case the navigator's note says HER2 positive, while the signed pathology report says HER2 negative. That kind of mismatch is what we want caught before the meeting.</a:t>
+              <a:t>Introduce the customer and the two users. The point is not that charts are hard to read. It is that the reviewer has to look in five places and compare them by eye. Each of the four demo cases has a planted problem, such as a navigator note that disagrees with the signed pathology or molecular report. That kind of mismatch is what we want caught before the meeting.</a:t>
             </a:r>
             <a:endParaRPr lang="en-US" dirty="0"/>
           </a:p>
@@ -995,7 +995,7 @@
           <a:p>
             <a:r>
               <a:rPr lang="en-US" dirty="0"/>
-              <a:t>This slide is the OpenAI side. A case coordinator agent on gpt-6.1-sol starts three specialists together. The patient data and history specialists read the record through an MCP server. The evidence specialist searches the Oncology Care Guidelines with File Search and looks up PubMed. The specialists use gpt-6.1-terra, which is faster and cheaper, because they are reading and extracting. A separate verifier checks the draft. Then the run pauses for the oncologist. Everything runs in the customer's own AWS account; only model calls and the guideline search go to OpenAI.</a:t>
+              <a:t>This slide is the OpenAI side. A case coordinator agent on gpt-6.1-sol starts four specialists together. The patient data and history specialists read the record through an MCP server that masks names, record numbers and birth dates before the model sees anything. The similar cases specialist searches a synthetic registry of past tumor board cases. The evidence specialist searches the Oncology Care Guidelines with File Search and looks up PubMed. The specialists use gpt-6.1-terra, which is faster and cheaper, because they are reading and extracting. A separate verifier checks the draft. Then the run pauses for the oncologist. Everything runs in the customer's own AWS account; only model calls and the guideline search go to OpenAI.</a:t>
             </a:r>
             <a:endParaRPr lang="en-US" dirty="0"/>
           </a:p>
@@ -1083,7 +1083,7 @@
           <a:p>
             <a:r>
               <a:rPr lang="en-US" dirty="0"/>
-              <a:t>Separate measured from assumed. Measured on the synthetic case: about 88 seconds of agent work and under ten cents of model cost per case, and 59 of 60 checks on the planted problems passed across ten runs. The one miss was a run that did not mention the old bone density scan. Assumed: forty cases a month and preparation dropping from seventy-five minutes to twenty-five, which gives about thirty-three hours a month. The dollar value of that time is modest. The bigger reason is catching conflicts before the meeting, which a pilot would measure.</a:t>
+              <a:t>Separate measured from assumed. Measured on the four synthetic cases: about 90 seconds of agent work and about ten cents of model cost per case. The checks on the planted problems are in the evaluation results file, with every miss listed. Assumed: forty cases a month and preparation dropping from seventy-five minutes to twenty-five, which gives about thirty-three hours a month. The dollar value of that time is modest. The bigger reason is catching conflicts before the meeting, which a pilot would measure.</a:t>
             </a:r>
             <a:endParaRPr lang="en-US" dirty="0"/>
           </a:p>
@@ -1848,7 +1848,7 @@
                   <a:schemeClr val="bg1"/>
                 </a:solidFill>
               </a:rPr>
-              <a:t>Preparing breast cancer cases for tumor board</a:t>
+              <a:t>Preparing cases for tumor board</a:t>
             </a:r>
             <a:endParaRPr lang="en-US" sz="3600" dirty="0"/>
           </a:p>
@@ -1901,7 +1901,7 @@
                   <a:schemeClr val="bg1"/>
                 </a:solidFill>
               </a:rPr>
-              <a:t>Lakeview Cancer Institute, a fictional regional cancer center with about 500 new breast cancer cases a year.</a:t>
+              <a:t>Lakeview Cancer Institute, a fictional regional cancer center that runs weekly tumor boards for breast, lung and colon cancer.</a:t>
             </a:r>
             <a:endParaRPr lang="en-US" sz="1800" dirty="0"/>
           </a:p>
@@ -1932,7 +1932,7 @@
                   <a:schemeClr val="bg1"/>
                 </a:solidFill>
               </a:rPr>
-              <a:t>Breast medical oncologists and nurse navigators, before the weekly tumor board.</a:t>
+              <a:t>Oncologists and nurse navigators who prepare each board's case list.</a:t>
             </a:r>
             <a:endParaRPr lang="en-US" sz="1800" dirty="0"/>
           </a:p>
@@ -2221,7 +2221,7 @@
                   <a:schemeClr val="bg1"/>
                 </a:solidFill>
               </a:rPr>
-              <a:t>1</a:t>
+              <a:t>4</a:t>
             </a:r>
             <a:endParaRPr lang="en-US" sz="3600" dirty="0"/>
           </a:p>
@@ -2257,7 +2257,7 @@
                   <a:schemeClr val="bg1"/>
                 </a:solidFill>
               </a:rPr>
-              <a:t>wrong HER2 label hidden in the demo case</a:t>
+              <a:t>demo cases across 3 tumor types, each with a hidden record problem</a:t>
             </a:r>
             <a:endParaRPr lang="en-US" sz="1400" dirty="0"/>
           </a:p>
@@ -2723,7 +2723,7 @@
                   <a:schemeClr val="tx1"/>
                 </a:solidFill>
               </a:rPr>
-              <a:t>A draft lists facts, guideline text and inference separately</a:t>
+              <a:t>A draft keeps patient facts, guideline text, similar past cases and inference separate</a:t>
             </a:r>
             <a:endParaRPr lang="en-US" sz="1600" dirty="0"/>
           </a:p>
@@ -2835,7 +2835,7 @@
                   <a:schemeClr val="bg1"/>
                 </a:solidFill>
               </a:rPr>
-              <a:t>Responses API for the model calls, Agents SDK for the case coordinator and specialists, File Search for the Oncology Care Guidelines, MCP for the patient record, tracing for review.</a:t>
+              <a:t>Responses API for the model calls, Agents SDK for the case coordinator and specialists, File Search for the Oncology Care Guidelines, MCP for the masked patient record and past cases, tracing for review.</a:t>
             </a:r>
             <a:endParaRPr lang="en-US" sz="1600" dirty="0"/>
           </a:p>
@@ -3163,7 +3163,7 @@
                   <a:schemeClr val="tx1"/>
                 </a:solidFill>
               </a:rPr>
-              <a:t>Three specialists start together and read the record and the Oncology Care Guidelines</a:t>
+              <a:t>Four specialists start together: record, history, guidelines and similar past cases</a:t>
             </a:r>
             <a:endParaRPr lang="en-US" sz="1400" dirty="0"/>
           </a:p>
@@ -3454,7 +3454,7 @@
                   <a:schemeClr val="tx1"/>
                 </a:solidFill>
               </a:rPr>
-              <a:t>The run pauses. Nothing is saved until the oncologist approves</a:t>
+              <a:t>Names and record numbers are masked first. The run pauses until the oncologist approves</a:t>
             </a:r>
             <a:endParaRPr lang="en-US" sz="1400" dirty="0"/>
           </a:p>
@@ -3641,7 +3641,7 @@
                   <a:schemeClr val="accent1"/>
                 </a:solidFill>
               </a:rPr>
-              <a:t>88 seconds</a:t>
+              <a:t>87 seconds</a:t>
             </a:r>
             <a:endParaRPr lang="en-US" sz="2200" dirty="0"/>
           </a:p>
@@ -3677,7 +3677,7 @@
                   <a:schemeClr val="tx1"/>
                 </a:solidFill>
               </a:rPr>
-              <a:t>of agent work per case, measured over 10 runs</a:t>
+              <a:t>of agent work per case, measured over 20 runs on 4 cases</a:t>
             </a:r>
             <a:endParaRPr lang="en-US" sz="1400" dirty="0"/>
           </a:p>
@@ -3839,7 +3839,7 @@
                   <a:schemeClr val="accent1"/>
                 </a:solidFill>
               </a:rPr>
-              <a:t>59 of 60 checks</a:t>
+              <a:t>168 of 170 checks</a:t>
             </a:r>
             <a:endParaRPr lang="en-US" sz="2200" dirty="0"/>
           </a:p>
@@ -3875,7 +3875,7 @@
                   <a:schemeClr val="tx1"/>
                 </a:solidFill>
               </a:rPr>
-              <a:t>on the planted problems passed across 10 runs</a:t>
+              <a:t>on the planted problems passed across 20 runs</a:t>
             </a:r>
             <a:endParaRPr lang="en-US" sz="1400" dirty="0"/>
           </a:p>
@@ -4010,7 +4010,7 @@
                   <a:schemeClr val="accent4"/>
                 </a:solidFill>
               </a:rPr>
-              <a:t>Time and cost are measured on the synthetic case. Hours saved is an assumption, editable in the value model. A pilot would measure real preparation times.</a:t>
+              <a:t>Time and cost are measured on the synthetic cases. Hours saved is an assumption, editable in the value model. A pilot would measure real preparation times.</a:t>
             </a:r>
             <a:endParaRPr lang="en-US" sz="1200" dirty="0"/>
           </a:p>

</xml_diff>

<commit_message>
Retry when a run ends without submitting, final evaluation results, deck and script updates
</commit_message>
<xml_diff>
--- a/deck/case-prep-deck.pptx
+++ b/deck/case-prep-deck.pptx
@@ -111,18 +111,18 @@
   <p:extLst>
     <p:ext uri="{521415D9-36F7-43E2-AB2F-B90AF26B5E84}">
       <p14:sectionLst xmlns:p14="http://schemas.microsoft.com/office/powerpoint/2010/main">
-        <p14:section name="Setup" id="{884a89ed-3ae8-e9cd-d439-9c00211be9b7}">
+        <p14:section name="Setup" id="{671df765-c530-3fee-6c86-6ff97e8d6136}">
           <p14:sldIdLst>
             <p14:sldId id="256"/>
             <p14:sldId id="257"/>
           </p14:sldIdLst>
         </p14:section>
-        <p14:section name="Demo" id="{cdebe692-9b56-0106-f58e-a3e86a942582}">
+        <p14:section name="Demo" id="{7847c791-2102-23ad-296f-1a673863bd90}">
           <p14:sldIdLst>
             <p14:sldId id="258"/>
           </p14:sldIdLst>
         </p14:section>
-        <p14:section name="Value" id="{336378a6-9236-846d-b5d3-4f415ca43a12}">
+        <p14:section name="Value" id="{a885a1bd-6744-5e7f-db1d-1be1d656b62c}">
           <p14:sldIdLst>
             <p14:sldId id="259"/>
             <p14:sldId id="260"/>
@@ -1083,7 +1083,7 @@
           <a:p>
             <a:r>
               <a:rPr lang="en-US" dirty="0"/>
-              <a:t>Separate measured from assumed. Measured on the four synthetic cases: about 90 seconds of agent work and about ten cents of model cost per case. The checks on the planted problems are in the evaluation results file, with every miss listed. Assumed: forty cases a month and preparation dropping from seventy-five minutes to twenty-five, which gives about thirty-three hours a month. The dollar value of that time is modest. The bigger reason is catching conflicts before the meeting, which a pilot would measure.</a:t>
+              <a:t>Separate measured from assumed. Measured on the four synthetic cases: about 85 seconds of agent work and about ten cents of model cost per case, and every check on the planted problems passed across twenty runs. Earlier runs missed a few checks before I tightened the instructions, which is why the evaluation is worth repeating on any change. Assumed: forty cases a month and preparation dropping from seventy-five minutes to twenty-five, which gives about thirty-three hours a month. The dollar value of that time is modest. The bigger reason is catching conflicts before the meeting, which a pilot would measure.</a:t>
             </a:r>
             <a:endParaRPr lang="en-US" dirty="0"/>
           </a:p>
@@ -3641,7 +3641,7 @@
                   <a:schemeClr val="accent1"/>
                 </a:solidFill>
               </a:rPr>
-              <a:t>87 seconds</a:t>
+              <a:t>85 seconds</a:t>
             </a:r>
             <a:endParaRPr lang="en-US" sz="2200" dirty="0"/>
           </a:p>
@@ -3839,7 +3839,7 @@
                   <a:schemeClr val="accent1"/>
                 </a:solidFill>
               </a:rPr>
-              <a:t>168 of 170 checks</a:t>
+              <a:t>170 of 170 checks</a:t>
             </a:r>
             <a:endParaRPr lang="en-US" sz="2200" dirty="0"/>
           </a:p>

</xml_diff>